<commit_message>
Add comparison slide: how proposed model differs from prior work
</commit_message>
<xml_diff>
--- a/results/ECG_Denoising_Presentation_24BEC0177.pptx
+++ b/results/ECG_Denoising_Presentation_24BEC0177.pptx
@@ -11,6 +11,7 @@
     <p:sldId id="259" r:id="rId10"/>
     <p:sldId id="260" r:id="rId11"/>
     <p:sldId id="261" r:id="rId12"/>
+    <p:sldId id="262" r:id="rId13"/>
   </p:sldIdLst>
   <p:sldSz cx="9144000" cy="6858000" type="screen4x3"/>
   <p:notesSz cx="6858000" cy="9144000"/>
@@ -3626,6 +3627,155 @@
             <a:pPr/>
             <a:r>
               <a:t>I acknowledge the MIT-BIH Arrhythmia Database and open-source Python ecosystem used in this project.</a:t>
+            </a:r>
+          </a:p>
+        </p:txBody>
+      </p:sp>
+    </p:spTree>
+  </p:cSld>
+  <p:clrMapOvr>
+    <a:masterClrMapping/>
+  </p:clrMapOvr>
+</p:sld>
+</file>
+
+<file path=ppt/slides/slide7.xml><?xml version="1.0" encoding="utf-8"?>
+<p:sld xmlns:a="http://schemas.openxmlformats.org/drawingml/2006/main" xmlns:p="http://schemas.openxmlformats.org/presentationml/2006/main" xmlns:r="http://schemas.openxmlformats.org/officeDocument/2006/relationships">
+  <p:cSld>
+    <p:spTree>
+      <p:nvGrpSpPr>
+        <p:cNvPr id="1" name=""/>
+        <p:cNvGrpSpPr/>
+        <p:nvPr/>
+      </p:nvGrpSpPr>
+      <p:grpSpPr/>
+      <p:sp>
+        <p:nvSpPr>
+          <p:cNvPr id="2" name="Title 1"/>
+          <p:cNvSpPr>
+            <a:spLocks noGrp="1"/>
+          </p:cNvSpPr>
+          <p:nvPr>
+            <p:ph type="title"/>
+          </p:nvPr>
+        </p:nvSpPr>
+        <p:spPr/>
+        <p:txBody>
+          <a:bodyPr/>
+          <a:lstStyle/>
+          <a:p>
+            <a:r>
+              <a:t>How Our Model Is Different</a:t>
+            </a:r>
+          </a:p>
+        </p:txBody>
+      </p:sp>
+      <p:sp>
+        <p:nvSpPr>
+          <p:cNvPr id="3" name="TextBox 2"/>
+          <p:cNvSpPr txBox="1"/>
+          <p:nvPr/>
+        </p:nvSpPr>
+        <p:spPr>
+          <a:xfrm>
+            <a:off x="548640" y="1188720"/>
+            <a:ext cx="5577840" cy="4937760"/>
+          </a:xfrm>
+          <a:prstGeom prst="rect">
+            <a:avLst/>
+          </a:prstGeom>
+          <a:noFill/>
+        </p:spPr>
+        <p:txBody>
+          <a:bodyPr wrap="none">
+            <a:spAutoFit/>
+          </a:bodyPr>
+          <a:lstStyle/>
+          <a:p>
+            <a:r>
+              <a:t>Previous Methods</a:t>
+            </a:r>
+          </a:p>
+          <a:p>
+            <a:pPr lvl="1"/>
+            <a:r>
+              <a:t>Use fixed wavelets (db4/sym5) not tailored to ECG morphology.</a:t>
+            </a:r>
+          </a:p>
+          <a:p>
+            <a:pPr lvl="1"/>
+            <a:r>
+              <a:t>Estimate noise globally (single sigma), often from finest scale only.</a:t>
+            </a:r>
+          </a:p>
+          <a:p>
+            <a:pPr lvl="1"/>
+            <a:r>
+              <a:t>Use hard/soft thresholding that can over-shrink QRS coefficients.</a:t>
+            </a:r>
+          </a:p>
+          <a:p>
+            <a:pPr lvl="1"/>
+            <a:r>
+              <a:t>Limited protection of R-peak sharpness during denoising.</a:t>
+            </a:r>
+          </a:p>
+        </p:txBody>
+      </p:sp>
+      <p:sp>
+        <p:nvSpPr>
+          <p:cNvPr id="4" name="TextBox 3"/>
+          <p:cNvSpPr txBox="1"/>
+          <p:nvPr/>
+        </p:nvSpPr>
+        <p:spPr>
+          <a:xfrm>
+            <a:off x="6217920" y="1188720"/>
+            <a:ext cx="5577840" cy="4937760"/>
+          </a:xfrm>
+          <a:prstGeom prst="rect">
+            <a:avLst/>
+          </a:prstGeom>
+          <a:noFill/>
+        </p:spPr>
+        <p:txBody>
+          <a:bodyPr wrap="none">
+            <a:spAutoFit/>
+          </a:bodyPr>
+          <a:lstStyle/>
+          <a:p>
+            <a:r>
+              <a:t>Our Proposed Model</a:t>
+            </a:r>
+          </a:p>
+          <a:p>
+            <a:pPr lvl="1"/>
+            <a:r>
+              <a:t>Designs a custom wavelet from CEEMDAN-selected ECG morphology (QRS-driven).</a:t>
+            </a:r>
+          </a:p>
+          <a:p>
+            <a:pPr lvl="1"/>
+            <a:r>
+              <a:t>Profiles noise per sub-band using CEEMDAN IMF-frequency mapping.</a:t>
+            </a:r>
+          </a:p>
+          <a:p>
+            <a:pPr lvl="1"/>
+            <a:r>
+              <a:t>Uses a 3-zone morphology-preserving thresholding function.</a:t>
+            </a:r>
+          </a:p>
+          <a:p>
+            <a:pPr lvl="1"/>
+            <a:r>
+              <a:t>Applies QRS mask protection in high-frequency levels to preserve R-peaks.</a:t>
+            </a:r>
+          </a:p>
+          <a:p>
+            <a:pPr lvl="1"/>
+            <a:r>
+              <a:t>Combines all three novelties in one end-to-end reconstruction pipeline.</a:t>
             </a:r>
           </a:p>
         </p:txBody>

</xml_diff>